<commit_message>
Finalize presentations and add the final one as PDF
</commit_message>
<xml_diff>
--- a/MyOwnPresentations/pptx/Abstract_Datatypes_V.pptx
+++ b/MyOwnPresentations/pptx/Abstract_Datatypes_V.pptx
@@ -12278,7 +12278,7 @@
           <a:p>
             <a:fld id="{16652C1E-0A75-4E3C-905C-182B2377573E}" type="datetimeFigureOut">
               <a:rPr lang="en-US" smtClean="0"/>
-              <a:t>9/5/2025</a:t>
+              <a:t>2/28/2026</a:t>
             </a:fld>
             <a:endParaRPr lang="en-US"/>
           </a:p>
@@ -12476,7 +12476,7 @@
           <a:p>
             <a:fld id="{16652C1E-0A75-4E3C-905C-182B2377573E}" type="datetimeFigureOut">
               <a:rPr lang="en-US" smtClean="0"/>
-              <a:t>9/5/2025</a:t>
+              <a:t>2/28/2026</a:t>
             </a:fld>
             <a:endParaRPr lang="en-US"/>
           </a:p>
@@ -12684,7 +12684,7 @@
           <a:p>
             <a:fld id="{16652C1E-0A75-4E3C-905C-182B2377573E}" type="datetimeFigureOut">
               <a:rPr lang="en-US" smtClean="0"/>
-              <a:t>9/5/2025</a:t>
+              <a:t>2/28/2026</a:t>
             </a:fld>
             <a:endParaRPr lang="en-US"/>
           </a:p>
@@ -12904,7 +12904,7 @@
           <a:p>
             <a:fld id="{5C041930-F8FC-4542-827E-E504F4750562}" type="datetimeFigureOut">
               <a:rPr lang="en-US" smtClean="0"/>
-              <a:t>9/5/2025</a:t>
+              <a:t>2/28/2026</a:t>
             </a:fld>
             <a:endParaRPr lang="en-US"/>
           </a:p>
@@ -13102,7 +13102,7 @@
           <a:p>
             <a:fld id="{5C041930-F8FC-4542-827E-E504F4750562}" type="datetimeFigureOut">
               <a:rPr lang="en-US" smtClean="0"/>
-              <a:t>9/5/2025</a:t>
+              <a:t>2/28/2026</a:t>
             </a:fld>
             <a:endParaRPr lang="en-US"/>
           </a:p>
@@ -13377,7 +13377,7 @@
           <a:p>
             <a:fld id="{5C041930-F8FC-4542-827E-E504F4750562}" type="datetimeFigureOut">
               <a:rPr lang="en-US" smtClean="0"/>
-              <a:t>9/5/2025</a:t>
+              <a:t>2/28/2026</a:t>
             </a:fld>
             <a:endParaRPr lang="en-US"/>
           </a:p>
@@ -13642,7 +13642,7 @@
           <a:p>
             <a:fld id="{5C041930-F8FC-4542-827E-E504F4750562}" type="datetimeFigureOut">
               <a:rPr lang="en-US" smtClean="0"/>
-              <a:t>9/5/2025</a:t>
+              <a:t>2/28/2026</a:t>
             </a:fld>
             <a:endParaRPr lang="en-US"/>
           </a:p>
@@ -14054,7 +14054,7 @@
           <a:p>
             <a:fld id="{5C041930-F8FC-4542-827E-E504F4750562}" type="datetimeFigureOut">
               <a:rPr lang="en-US" smtClean="0"/>
-              <a:t>9/5/2025</a:t>
+              <a:t>2/28/2026</a:t>
             </a:fld>
             <a:endParaRPr lang="en-US"/>
           </a:p>
@@ -14195,7 +14195,7 @@
           <a:p>
             <a:fld id="{5C041930-F8FC-4542-827E-E504F4750562}" type="datetimeFigureOut">
               <a:rPr lang="en-US" smtClean="0"/>
-              <a:t>9/5/2025</a:t>
+              <a:t>2/28/2026</a:t>
             </a:fld>
             <a:endParaRPr lang="en-US"/>
           </a:p>
@@ -14308,7 +14308,7 @@
           <a:p>
             <a:fld id="{5C041930-F8FC-4542-827E-E504F4750562}" type="datetimeFigureOut">
               <a:rPr lang="en-US" smtClean="0"/>
-              <a:t>9/5/2025</a:t>
+              <a:t>2/28/2026</a:t>
             </a:fld>
             <a:endParaRPr lang="en-US"/>
           </a:p>
@@ -14619,7 +14619,7 @@
           <a:p>
             <a:fld id="{5C041930-F8FC-4542-827E-E504F4750562}" type="datetimeFigureOut">
               <a:rPr lang="en-US" smtClean="0"/>
-              <a:t>9/5/2025</a:t>
+              <a:t>2/28/2026</a:t>
             </a:fld>
             <a:endParaRPr lang="en-US"/>
           </a:p>
@@ -14817,7 +14817,7 @@
           <a:p>
             <a:fld id="{16652C1E-0A75-4E3C-905C-182B2377573E}" type="datetimeFigureOut">
               <a:rPr lang="en-US" smtClean="0"/>
-              <a:t>9/5/2025</a:t>
+              <a:t>2/28/2026</a:t>
             </a:fld>
             <a:endParaRPr lang="en-US"/>
           </a:p>
@@ -15105,7 +15105,7 @@
           <a:p>
             <a:fld id="{5C041930-F8FC-4542-827E-E504F4750562}" type="datetimeFigureOut">
               <a:rPr lang="en-US" smtClean="0"/>
-              <a:t>9/5/2025</a:t>
+              <a:t>2/28/2026</a:t>
             </a:fld>
             <a:endParaRPr lang="en-US"/>
           </a:p>
@@ -15303,7 +15303,7 @@
           <a:p>
             <a:fld id="{5C041930-F8FC-4542-827E-E504F4750562}" type="datetimeFigureOut">
               <a:rPr lang="en-US" smtClean="0"/>
-              <a:t>9/5/2025</a:t>
+              <a:t>2/28/2026</a:t>
             </a:fld>
             <a:endParaRPr lang="en-US"/>
           </a:p>
@@ -15511,7 +15511,7 @@
           <a:p>
             <a:fld id="{5C041930-F8FC-4542-827E-E504F4750562}" type="datetimeFigureOut">
               <a:rPr lang="en-US" smtClean="0"/>
-              <a:t>9/5/2025</a:t>
+              <a:t>2/28/2026</a:t>
             </a:fld>
             <a:endParaRPr lang="en-US"/>
           </a:p>
@@ -15786,7 +15786,7 @@
           <a:p>
             <a:fld id="{16652C1E-0A75-4E3C-905C-182B2377573E}" type="datetimeFigureOut">
               <a:rPr lang="en-US" smtClean="0"/>
-              <a:t>9/5/2025</a:t>
+              <a:t>2/28/2026</a:t>
             </a:fld>
             <a:endParaRPr lang="en-US"/>
           </a:p>
@@ -16051,7 +16051,7 @@
           <a:p>
             <a:fld id="{16652C1E-0A75-4E3C-905C-182B2377573E}" type="datetimeFigureOut">
               <a:rPr lang="en-US" smtClean="0"/>
-              <a:t>9/5/2025</a:t>
+              <a:t>2/28/2026</a:t>
             </a:fld>
             <a:endParaRPr lang="en-US"/>
           </a:p>
@@ -16463,7 +16463,7 @@
           <a:p>
             <a:fld id="{16652C1E-0A75-4E3C-905C-182B2377573E}" type="datetimeFigureOut">
               <a:rPr lang="en-US" smtClean="0"/>
-              <a:t>9/5/2025</a:t>
+              <a:t>2/28/2026</a:t>
             </a:fld>
             <a:endParaRPr lang="en-US"/>
           </a:p>
@@ -16604,7 +16604,7 @@
           <a:p>
             <a:fld id="{16652C1E-0A75-4E3C-905C-182B2377573E}" type="datetimeFigureOut">
               <a:rPr lang="en-US" smtClean="0"/>
-              <a:t>9/5/2025</a:t>
+              <a:t>2/28/2026</a:t>
             </a:fld>
             <a:endParaRPr lang="en-US"/>
           </a:p>
@@ -16717,7 +16717,7 @@
           <a:p>
             <a:fld id="{16652C1E-0A75-4E3C-905C-182B2377573E}" type="datetimeFigureOut">
               <a:rPr lang="en-US" smtClean="0"/>
-              <a:t>9/5/2025</a:t>
+              <a:t>2/28/2026</a:t>
             </a:fld>
             <a:endParaRPr lang="en-US"/>
           </a:p>
@@ -17028,7 +17028,7 @@
           <a:p>
             <a:fld id="{16652C1E-0A75-4E3C-905C-182B2377573E}" type="datetimeFigureOut">
               <a:rPr lang="en-US" smtClean="0"/>
-              <a:t>9/5/2025</a:t>
+              <a:t>2/28/2026</a:t>
             </a:fld>
             <a:endParaRPr lang="en-US"/>
           </a:p>
@@ -17316,7 +17316,7 @@
           <a:p>
             <a:fld id="{16652C1E-0A75-4E3C-905C-182B2377573E}" type="datetimeFigureOut">
               <a:rPr lang="en-US" smtClean="0"/>
-              <a:t>9/5/2025</a:t>
+              <a:t>2/28/2026</a:t>
             </a:fld>
             <a:endParaRPr lang="en-US"/>
           </a:p>
@@ -17557,7 +17557,7 @@
           <a:p>
             <a:fld id="{16652C1E-0A75-4E3C-905C-182B2377573E}" type="datetimeFigureOut">
               <a:rPr lang="en-US" smtClean="0"/>
-              <a:t>9/5/2025</a:t>
+              <a:t>2/28/2026</a:t>
             </a:fld>
             <a:endParaRPr lang="en-US"/>
           </a:p>
@@ -18125,7 +18125,7 @@
           <a:p>
             <a:fld id="{5C041930-F8FC-4542-827E-E504F4750562}" type="datetimeFigureOut">
               <a:rPr lang="en-US" smtClean="0"/>
-              <a:t>9/5/2025</a:t>
+              <a:t>2/28/2026</a:t>
             </a:fld>
             <a:endParaRPr lang="en-US"/>
           </a:p>
@@ -19065,7 +19065,7 @@
                   <a:srgbClr val="FFFFFF"/>
                 </a:solidFill>
               </a:rPr>
-              <a:t>2025/26. Autumn Semester</a:t>
+              <a:t>2025/26. Spring Semester</a:t>
             </a:r>
           </a:p>
           <a:p>
@@ -27092,93 +27092,93 @@
           <a:custGeom>
             <a:avLst/>
             <a:gdLst>
-              <a:gd name="connsiteX0" fmla="*/ 0 w 4572000"/>
-              <a:gd name="connsiteY0" fmla="*/ 0 h 18288"/>
-              <a:gd name="connsiteX1" fmla="*/ 515983 w 4572000"/>
-              <a:gd name="connsiteY1" fmla="*/ 0 h 18288"/>
-              <a:gd name="connsiteX2" fmla="*/ 1031966 w 4572000"/>
-              <a:gd name="connsiteY2" fmla="*/ 0 h 18288"/>
-              <a:gd name="connsiteX3" fmla="*/ 1639389 w 4572000"/>
-              <a:gd name="connsiteY3" fmla="*/ 0 h 18288"/>
-              <a:gd name="connsiteX4" fmla="*/ 2383971 w 4572000"/>
-              <a:gd name="connsiteY4" fmla="*/ 0 h 18288"/>
-              <a:gd name="connsiteX5" fmla="*/ 2945674 w 4572000"/>
-              <a:gd name="connsiteY5" fmla="*/ 0 h 18288"/>
-              <a:gd name="connsiteX6" fmla="*/ 3507377 w 4572000"/>
-              <a:gd name="connsiteY6" fmla="*/ 0 h 18288"/>
-              <a:gd name="connsiteX7" fmla="*/ 4572000 w 4572000"/>
-              <a:gd name="connsiteY7" fmla="*/ 0 h 18288"/>
-              <a:gd name="connsiteX8" fmla="*/ 4572000 w 4572000"/>
-              <a:gd name="connsiteY8" fmla="*/ 18288 h 18288"/>
-              <a:gd name="connsiteX9" fmla="*/ 3873137 w 4572000"/>
-              <a:gd name="connsiteY9" fmla="*/ 18288 h 18288"/>
-              <a:gd name="connsiteX10" fmla="*/ 3311434 w 4572000"/>
-              <a:gd name="connsiteY10" fmla="*/ 18288 h 18288"/>
-              <a:gd name="connsiteX11" fmla="*/ 2749731 w 4572000"/>
-              <a:gd name="connsiteY11" fmla="*/ 18288 h 18288"/>
-              <a:gd name="connsiteX12" fmla="*/ 2050869 w 4572000"/>
-              <a:gd name="connsiteY12" fmla="*/ 18288 h 18288"/>
-              <a:gd name="connsiteX13" fmla="*/ 1306286 w 4572000"/>
-              <a:gd name="connsiteY13" fmla="*/ 18288 h 18288"/>
-              <a:gd name="connsiteX14" fmla="*/ 790303 w 4572000"/>
-              <a:gd name="connsiteY14" fmla="*/ 18288 h 18288"/>
-              <a:gd name="connsiteX15" fmla="*/ 0 w 4572000"/>
-              <a:gd name="connsiteY15" fmla="*/ 18288 h 18288"/>
-              <a:gd name="connsiteX16" fmla="*/ 0 w 4572000"/>
-              <a:gd name="connsiteY16" fmla="*/ 0 h 18288"/>
+              <a:gd name="csX0" fmla="*/ 0 w 4572000"/>
+              <a:gd name="csY0" fmla="*/ 0 h 18288"/>
+              <a:gd name="csX1" fmla="*/ 515983 w 4572000"/>
+              <a:gd name="csY1" fmla="*/ 0 h 18288"/>
+              <a:gd name="csX2" fmla="*/ 1031966 w 4572000"/>
+              <a:gd name="csY2" fmla="*/ 0 h 18288"/>
+              <a:gd name="csX3" fmla="*/ 1639389 w 4572000"/>
+              <a:gd name="csY3" fmla="*/ 0 h 18288"/>
+              <a:gd name="csX4" fmla="*/ 2383971 w 4572000"/>
+              <a:gd name="csY4" fmla="*/ 0 h 18288"/>
+              <a:gd name="csX5" fmla="*/ 2945674 w 4572000"/>
+              <a:gd name="csY5" fmla="*/ 0 h 18288"/>
+              <a:gd name="csX6" fmla="*/ 3507377 w 4572000"/>
+              <a:gd name="csY6" fmla="*/ 0 h 18288"/>
+              <a:gd name="csX7" fmla="*/ 4572000 w 4572000"/>
+              <a:gd name="csY7" fmla="*/ 0 h 18288"/>
+              <a:gd name="csX8" fmla="*/ 4572000 w 4572000"/>
+              <a:gd name="csY8" fmla="*/ 18288 h 18288"/>
+              <a:gd name="csX9" fmla="*/ 3873137 w 4572000"/>
+              <a:gd name="csY9" fmla="*/ 18288 h 18288"/>
+              <a:gd name="csX10" fmla="*/ 3311434 w 4572000"/>
+              <a:gd name="csY10" fmla="*/ 18288 h 18288"/>
+              <a:gd name="csX11" fmla="*/ 2749731 w 4572000"/>
+              <a:gd name="csY11" fmla="*/ 18288 h 18288"/>
+              <a:gd name="csX12" fmla="*/ 2050869 w 4572000"/>
+              <a:gd name="csY12" fmla="*/ 18288 h 18288"/>
+              <a:gd name="csX13" fmla="*/ 1306286 w 4572000"/>
+              <a:gd name="csY13" fmla="*/ 18288 h 18288"/>
+              <a:gd name="csX14" fmla="*/ 790303 w 4572000"/>
+              <a:gd name="csY14" fmla="*/ 18288 h 18288"/>
+              <a:gd name="csX15" fmla="*/ 0 w 4572000"/>
+              <a:gd name="csY15" fmla="*/ 18288 h 18288"/>
+              <a:gd name="csX16" fmla="*/ 0 w 4572000"/>
+              <a:gd name="csY16" fmla="*/ 0 h 18288"/>
             </a:gdLst>
             <a:ahLst/>
             <a:cxnLst>
               <a:cxn ang="0">
-                <a:pos x="connsiteX0" y="connsiteY0"/>
+                <a:pos x="csX0" y="csY0"/>
               </a:cxn>
               <a:cxn ang="0">
-                <a:pos x="connsiteX1" y="connsiteY1"/>
+                <a:pos x="csX1" y="csY1"/>
               </a:cxn>
               <a:cxn ang="0">
-                <a:pos x="connsiteX2" y="connsiteY2"/>
+                <a:pos x="csX2" y="csY2"/>
               </a:cxn>
               <a:cxn ang="0">
-                <a:pos x="connsiteX3" y="connsiteY3"/>
+                <a:pos x="csX3" y="csY3"/>
               </a:cxn>
               <a:cxn ang="0">
-                <a:pos x="connsiteX4" y="connsiteY4"/>
+                <a:pos x="csX4" y="csY4"/>
               </a:cxn>
               <a:cxn ang="0">
-                <a:pos x="connsiteX5" y="connsiteY5"/>
+                <a:pos x="csX5" y="csY5"/>
               </a:cxn>
               <a:cxn ang="0">
-                <a:pos x="connsiteX6" y="connsiteY6"/>
+                <a:pos x="csX6" y="csY6"/>
               </a:cxn>
               <a:cxn ang="0">
-                <a:pos x="connsiteX7" y="connsiteY7"/>
+                <a:pos x="csX7" y="csY7"/>
               </a:cxn>
               <a:cxn ang="0">
-                <a:pos x="connsiteX8" y="connsiteY8"/>
+                <a:pos x="csX8" y="csY8"/>
               </a:cxn>
               <a:cxn ang="0">
-                <a:pos x="connsiteX9" y="connsiteY9"/>
+                <a:pos x="csX9" y="csY9"/>
               </a:cxn>
               <a:cxn ang="0">
-                <a:pos x="connsiteX10" y="connsiteY10"/>
+                <a:pos x="csX10" y="csY10"/>
               </a:cxn>
               <a:cxn ang="0">
-                <a:pos x="connsiteX11" y="connsiteY11"/>
+                <a:pos x="csX11" y="csY11"/>
               </a:cxn>
               <a:cxn ang="0">
-                <a:pos x="connsiteX12" y="connsiteY12"/>
+                <a:pos x="csX12" y="csY12"/>
               </a:cxn>
               <a:cxn ang="0">
-                <a:pos x="connsiteX13" y="connsiteY13"/>
+                <a:pos x="csX13" y="csY13"/>
               </a:cxn>
               <a:cxn ang="0">
-                <a:pos x="connsiteX14" y="connsiteY14"/>
+                <a:pos x="csX14" y="csY14"/>
               </a:cxn>
               <a:cxn ang="0">
-                <a:pos x="connsiteX15" y="connsiteY15"/>
+                <a:pos x="csX15" y="csY15"/>
               </a:cxn>
               <a:cxn ang="0">
-                <a:pos x="connsiteX16" y="connsiteY16"/>
+                <a:pos x="csX16" y="csY16"/>
               </a:cxn>
             </a:cxnLst>
             <a:rect l="l" t="t" r="r" b="b"/>

</xml_diff>